<commit_message>
backup: before 열린소통 ON v2 integration
</commit_message>
<xml_diff>
--- a/yeonggwang_proposal.pptx
+++ b/yeonggwang_proposal.pptx
@@ -5,17 +5,17 @@
     <p:sldMasterId id="2147483648" r:id="rId1"/>
   </p:sldMasterIdLst>
   <p:sldIdLst>
-    <p:sldId id="256" r:id="rId7"/>
-    <p:sldId id="257" r:id="rId8"/>
-    <p:sldId id="258" r:id="rId9"/>
-    <p:sldId id="259" r:id="rId10"/>
-    <p:sldId id="260" r:id="rId11"/>
-    <p:sldId id="261" r:id="rId12"/>
-    <p:sldId id="262" r:id="rId13"/>
-    <p:sldId id="263" r:id="rId14"/>
-    <p:sldId id="264" r:id="rId15"/>
+    <p:sldId id="256" r:id="rId2"/>
+    <p:sldId id="257" r:id="rId3"/>
+    <p:sldId id="258" r:id="rId4"/>
+    <p:sldId id="259" r:id="rId5"/>
+    <p:sldId id="260" r:id="rId6"/>
+    <p:sldId id="261" r:id="rId7"/>
+    <p:sldId id="262" r:id="rId8"/>
+    <p:sldId id="263" r:id="rId9"/>
+    <p:sldId id="264" r:id="rId10"/>
   </p:sldIdLst>
-  <p:sldSz cx="12191695" cy="6858000" type="screen4x3"/>
+  <p:sldSz cx="12192000" cy="6858000"/>
   <p:notesSz cx="6858000" cy="9144000"/>
   <p:defaultTextStyle>
     <a:defPPr>
@@ -112,6 +112,22 @@
       </a:defRPr>
     </a:lvl9pPr>
   </p:defaultTextStyle>
+  <p:extLst>
+    <p:ext uri="{EFAFB233-063F-42B5-8137-9DF3F51BA10A}">
+      <p15:sldGuideLst xmlns:p15="http://schemas.microsoft.com/office/powerpoint/2012/main">
+        <p15:guide id="1" orient="horz" pos="2160">
+          <p15:clr>
+            <a:srgbClr val="A4A3A4"/>
+          </p15:clr>
+        </p15:guide>
+        <p15:guide id="2" pos="2880">
+          <p15:clr>
+            <a:srgbClr val="A4A3A4"/>
+          </p15:clr>
+        </p15:guide>
+      </p15:sldGuideLst>
+    </p:ext>
+  </p:extLst>
 </p:presentation>
 </file>
 
@@ -153,10 +169,9 @@
           <a:lstStyle/>
           <a:p>
             <a:r>
-              <a:rPr lang="en-US" smtClean="0"/>
+              <a:rPr lang="en-US"/>
               <a:t>Click to edit Master title style</a:t>
             </a:r>
-            <a:endParaRPr lang="en-US"/>
           </a:p>
         </p:txBody>
       </p:sp>
@@ -272,10 +287,9 @@
           </a:lstStyle>
           <a:p>
             <a:r>
-              <a:rPr lang="en-US" smtClean="0"/>
+              <a:rPr lang="en-US"/>
               <a:t>Click to edit Master subtitle style</a:t>
             </a:r>
-            <a:endParaRPr lang="en-US"/>
           </a:p>
         </p:txBody>
       </p:sp>
@@ -296,7 +310,7 @@
           <a:p>
             <a:fld id="{5BCAD085-E8A6-8845-BD4E-CB4CCA059FC4}" type="datetimeFigureOut">
               <a:rPr lang="en-US" smtClean="0"/>
-              <a:t>1/27/13</a:t>
+              <a:t>8/3/26</a:t>
             </a:fld>
             <a:endParaRPr lang="en-US"/>
           </a:p>
@@ -390,10 +404,9 @@
           <a:lstStyle/>
           <a:p>
             <a:r>
-              <a:rPr lang="en-US" smtClean="0"/>
+              <a:rPr lang="en-US"/>
               <a:t>Click to edit Master title style</a:t>
             </a:r>
-            <a:endParaRPr lang="en-US"/>
           </a:p>
         </p:txBody>
       </p:sp>
@@ -414,38 +427,37 @@
           <a:p>
             <a:pPr lvl="0"/>
             <a:r>
-              <a:rPr lang="en-US" smtClean="0"/>
+              <a:rPr lang="en-US"/>
               <a:t>Click to edit Master text styles</a:t>
             </a:r>
           </a:p>
           <a:p>
             <a:pPr lvl="1"/>
             <a:r>
-              <a:rPr lang="en-US" smtClean="0"/>
+              <a:rPr lang="en-US"/>
               <a:t>Second level</a:t>
             </a:r>
           </a:p>
           <a:p>
             <a:pPr lvl="2"/>
             <a:r>
-              <a:rPr lang="en-US" smtClean="0"/>
+              <a:rPr lang="en-US"/>
               <a:t>Third level</a:t>
             </a:r>
           </a:p>
           <a:p>
             <a:pPr lvl="3"/>
             <a:r>
-              <a:rPr lang="en-US" smtClean="0"/>
+              <a:rPr lang="en-US"/>
               <a:t>Fourth level</a:t>
             </a:r>
           </a:p>
           <a:p>
             <a:pPr lvl="4"/>
             <a:r>
-              <a:rPr lang="en-US" smtClean="0"/>
+              <a:rPr lang="en-US"/>
               <a:t>Fifth level</a:t>
             </a:r>
-            <a:endParaRPr lang="en-US"/>
           </a:p>
         </p:txBody>
       </p:sp>
@@ -466,7 +478,7 @@
           <a:p>
             <a:fld id="{5BCAD085-E8A6-8845-BD4E-CB4CCA059FC4}" type="datetimeFigureOut">
               <a:rPr lang="en-US" smtClean="0"/>
-              <a:t>1/27/13</a:t>
+              <a:t>8/3/26</a:t>
             </a:fld>
             <a:endParaRPr lang="en-US"/>
           </a:p>
@@ -565,10 +577,9 @@
           <a:lstStyle/>
           <a:p>
             <a:r>
-              <a:rPr lang="en-US" smtClean="0"/>
+              <a:rPr lang="en-US"/>
               <a:t>Click to edit Master title style</a:t>
             </a:r>
-            <a:endParaRPr lang="en-US"/>
           </a:p>
         </p:txBody>
       </p:sp>
@@ -594,38 +605,37 @@
           <a:p>
             <a:pPr lvl="0"/>
             <a:r>
-              <a:rPr lang="en-US" smtClean="0"/>
+              <a:rPr lang="en-US"/>
               <a:t>Click to edit Master text styles</a:t>
             </a:r>
           </a:p>
           <a:p>
             <a:pPr lvl="1"/>
             <a:r>
-              <a:rPr lang="en-US" smtClean="0"/>
+              <a:rPr lang="en-US"/>
               <a:t>Second level</a:t>
             </a:r>
           </a:p>
           <a:p>
             <a:pPr lvl="2"/>
             <a:r>
-              <a:rPr lang="en-US" smtClean="0"/>
+              <a:rPr lang="en-US"/>
               <a:t>Third level</a:t>
             </a:r>
           </a:p>
           <a:p>
             <a:pPr lvl="3"/>
             <a:r>
-              <a:rPr lang="en-US" smtClean="0"/>
+              <a:rPr lang="en-US"/>
               <a:t>Fourth level</a:t>
             </a:r>
           </a:p>
           <a:p>
             <a:pPr lvl="4"/>
             <a:r>
-              <a:rPr lang="en-US" smtClean="0"/>
+              <a:rPr lang="en-US"/>
               <a:t>Fifth level</a:t>
             </a:r>
-            <a:endParaRPr lang="en-US"/>
           </a:p>
         </p:txBody>
       </p:sp>
@@ -646,7 +656,7 @@
           <a:p>
             <a:fld id="{5BCAD085-E8A6-8845-BD4E-CB4CCA059FC4}" type="datetimeFigureOut">
               <a:rPr lang="en-US" smtClean="0"/>
-              <a:t>1/27/13</a:t>
+              <a:t>8/3/26</a:t>
             </a:fld>
             <a:endParaRPr lang="en-US"/>
           </a:p>
@@ -740,10 +750,9 @@
           <a:lstStyle/>
           <a:p>
             <a:r>
-              <a:rPr lang="en-US" smtClean="0"/>
+              <a:rPr lang="en-US"/>
               <a:t>Click to edit Master title style</a:t>
             </a:r>
-            <a:endParaRPr lang="en-US"/>
           </a:p>
         </p:txBody>
       </p:sp>
@@ -764,38 +773,37 @@
           <a:p>
             <a:pPr lvl="0"/>
             <a:r>
-              <a:rPr lang="en-US" smtClean="0"/>
+              <a:rPr lang="en-US"/>
               <a:t>Click to edit Master text styles</a:t>
             </a:r>
           </a:p>
           <a:p>
             <a:pPr lvl="1"/>
             <a:r>
-              <a:rPr lang="en-US" smtClean="0"/>
+              <a:rPr lang="en-US"/>
               <a:t>Second level</a:t>
             </a:r>
           </a:p>
           <a:p>
             <a:pPr lvl="2"/>
             <a:r>
-              <a:rPr lang="en-US" smtClean="0"/>
+              <a:rPr lang="en-US"/>
               <a:t>Third level</a:t>
             </a:r>
           </a:p>
           <a:p>
             <a:pPr lvl="3"/>
             <a:r>
-              <a:rPr lang="en-US" smtClean="0"/>
+              <a:rPr lang="en-US"/>
               <a:t>Fourth level</a:t>
             </a:r>
           </a:p>
           <a:p>
             <a:pPr lvl="4"/>
             <a:r>
-              <a:rPr lang="en-US" smtClean="0"/>
+              <a:rPr lang="en-US"/>
               <a:t>Fifth level</a:t>
             </a:r>
-            <a:endParaRPr lang="en-US"/>
           </a:p>
         </p:txBody>
       </p:sp>
@@ -816,7 +824,7 @@
           <a:p>
             <a:fld id="{5BCAD085-E8A6-8845-BD4E-CB4CCA059FC4}" type="datetimeFigureOut">
               <a:rPr lang="en-US" smtClean="0"/>
-              <a:t>1/27/13</a:t>
+              <a:t>8/3/26</a:t>
             </a:fld>
             <a:endParaRPr lang="en-US"/>
           </a:p>
@@ -919,10 +927,9 @@
           </a:lstStyle>
           <a:p>
             <a:r>
-              <a:rPr lang="en-US" smtClean="0"/>
+              <a:rPr lang="en-US"/>
               <a:t>Click to edit Master title style</a:t>
             </a:r>
-            <a:endParaRPr lang="en-US"/>
           </a:p>
         </p:txBody>
       </p:sp>
@@ -1039,7 +1046,7 @@
           <a:p>
             <a:pPr lvl="0"/>
             <a:r>
-              <a:rPr lang="en-US" smtClean="0"/>
+              <a:rPr lang="en-US"/>
               <a:t>Click to edit Master text styles</a:t>
             </a:r>
           </a:p>
@@ -1062,7 +1069,7 @@
           <a:p>
             <a:fld id="{5BCAD085-E8A6-8845-BD4E-CB4CCA059FC4}" type="datetimeFigureOut">
               <a:rPr lang="en-US" smtClean="0"/>
-              <a:t>1/27/13</a:t>
+              <a:t>8/3/26</a:t>
             </a:fld>
             <a:endParaRPr lang="en-US"/>
           </a:p>
@@ -1156,10 +1163,9 @@
           <a:lstStyle/>
           <a:p>
             <a:r>
-              <a:rPr lang="en-US" smtClean="0"/>
+              <a:rPr lang="en-US"/>
               <a:t>Click to edit Master title style</a:t>
             </a:r>
-            <a:endParaRPr lang="en-US"/>
           </a:p>
         </p:txBody>
       </p:sp>
@@ -1213,38 +1219,37 @@
           <a:p>
             <a:pPr lvl="0"/>
             <a:r>
-              <a:rPr lang="en-US" smtClean="0"/>
+              <a:rPr lang="en-US"/>
               <a:t>Click to edit Master text styles</a:t>
             </a:r>
           </a:p>
           <a:p>
             <a:pPr lvl="1"/>
             <a:r>
-              <a:rPr lang="en-US" smtClean="0"/>
+              <a:rPr lang="en-US"/>
               <a:t>Second level</a:t>
             </a:r>
           </a:p>
           <a:p>
             <a:pPr lvl="2"/>
             <a:r>
-              <a:rPr lang="en-US" smtClean="0"/>
+              <a:rPr lang="en-US"/>
               <a:t>Third level</a:t>
             </a:r>
           </a:p>
           <a:p>
             <a:pPr lvl="3"/>
             <a:r>
-              <a:rPr lang="en-US" smtClean="0"/>
+              <a:rPr lang="en-US"/>
               <a:t>Fourth level</a:t>
             </a:r>
           </a:p>
           <a:p>
             <a:pPr lvl="4"/>
             <a:r>
-              <a:rPr lang="en-US" smtClean="0"/>
+              <a:rPr lang="en-US"/>
               <a:t>Fifth level</a:t>
             </a:r>
-            <a:endParaRPr lang="en-US"/>
           </a:p>
         </p:txBody>
       </p:sp>
@@ -1298,38 +1303,37 @@
           <a:p>
             <a:pPr lvl="0"/>
             <a:r>
-              <a:rPr lang="en-US" smtClean="0"/>
+              <a:rPr lang="en-US"/>
               <a:t>Click to edit Master text styles</a:t>
             </a:r>
           </a:p>
           <a:p>
             <a:pPr lvl="1"/>
             <a:r>
-              <a:rPr lang="en-US" smtClean="0"/>
+              <a:rPr lang="en-US"/>
               <a:t>Second level</a:t>
             </a:r>
           </a:p>
           <a:p>
             <a:pPr lvl="2"/>
             <a:r>
-              <a:rPr lang="en-US" smtClean="0"/>
+              <a:rPr lang="en-US"/>
               <a:t>Third level</a:t>
             </a:r>
           </a:p>
           <a:p>
             <a:pPr lvl="3"/>
             <a:r>
-              <a:rPr lang="en-US" smtClean="0"/>
+              <a:rPr lang="en-US"/>
               <a:t>Fourth level</a:t>
             </a:r>
           </a:p>
           <a:p>
             <a:pPr lvl="4"/>
             <a:r>
-              <a:rPr lang="en-US" smtClean="0"/>
+              <a:rPr lang="en-US"/>
               <a:t>Fifth level</a:t>
             </a:r>
-            <a:endParaRPr lang="en-US"/>
           </a:p>
         </p:txBody>
       </p:sp>
@@ -1350,7 +1354,7 @@
           <a:p>
             <a:fld id="{5BCAD085-E8A6-8845-BD4E-CB4CCA059FC4}" type="datetimeFigureOut">
               <a:rPr lang="en-US" smtClean="0"/>
-              <a:t>1/27/13</a:t>
+              <a:t>8/3/26</a:t>
             </a:fld>
             <a:endParaRPr lang="en-US"/>
           </a:p>
@@ -1448,10 +1452,9 @@
           </a:lstStyle>
           <a:p>
             <a:r>
-              <a:rPr lang="en-US" smtClean="0"/>
+              <a:rPr lang="en-US"/>
               <a:t>Click to edit Master title style</a:t>
             </a:r>
-            <a:endParaRPr lang="en-US"/>
           </a:p>
         </p:txBody>
       </p:sp>
@@ -1514,7 +1517,7 @@
           <a:p>
             <a:pPr lvl="0"/>
             <a:r>
-              <a:rPr lang="en-US" smtClean="0"/>
+              <a:rPr lang="en-US"/>
               <a:t>Click to edit Master text styles</a:t>
             </a:r>
           </a:p>
@@ -1570,38 +1573,37 @@
           <a:p>
             <a:pPr lvl="0"/>
             <a:r>
-              <a:rPr lang="en-US" smtClean="0"/>
+              <a:rPr lang="en-US"/>
               <a:t>Click to edit Master text styles</a:t>
             </a:r>
           </a:p>
           <a:p>
             <a:pPr lvl="1"/>
             <a:r>
-              <a:rPr lang="en-US" smtClean="0"/>
+              <a:rPr lang="en-US"/>
               <a:t>Second level</a:t>
             </a:r>
           </a:p>
           <a:p>
             <a:pPr lvl="2"/>
             <a:r>
-              <a:rPr lang="en-US" smtClean="0"/>
+              <a:rPr lang="en-US"/>
               <a:t>Third level</a:t>
             </a:r>
           </a:p>
           <a:p>
             <a:pPr lvl="3"/>
             <a:r>
-              <a:rPr lang="en-US" smtClean="0"/>
+              <a:rPr lang="en-US"/>
               <a:t>Fourth level</a:t>
             </a:r>
           </a:p>
           <a:p>
             <a:pPr lvl="4"/>
             <a:r>
-              <a:rPr lang="en-US" smtClean="0"/>
+              <a:rPr lang="en-US"/>
               <a:t>Fifth level</a:t>
             </a:r>
-            <a:endParaRPr lang="en-US"/>
           </a:p>
         </p:txBody>
       </p:sp>
@@ -1664,7 +1666,7 @@
           <a:p>
             <a:pPr lvl="0"/>
             <a:r>
-              <a:rPr lang="en-US" smtClean="0"/>
+              <a:rPr lang="en-US"/>
               <a:t>Click to edit Master text styles</a:t>
             </a:r>
           </a:p>
@@ -1720,38 +1722,37 @@
           <a:p>
             <a:pPr lvl="0"/>
             <a:r>
-              <a:rPr lang="en-US" smtClean="0"/>
+              <a:rPr lang="en-US"/>
               <a:t>Click to edit Master text styles</a:t>
             </a:r>
           </a:p>
           <a:p>
             <a:pPr lvl="1"/>
             <a:r>
-              <a:rPr lang="en-US" smtClean="0"/>
+              <a:rPr lang="en-US"/>
               <a:t>Second level</a:t>
             </a:r>
           </a:p>
           <a:p>
             <a:pPr lvl="2"/>
             <a:r>
-              <a:rPr lang="en-US" smtClean="0"/>
+              <a:rPr lang="en-US"/>
               <a:t>Third level</a:t>
             </a:r>
           </a:p>
           <a:p>
             <a:pPr lvl="3"/>
             <a:r>
-              <a:rPr lang="en-US" smtClean="0"/>
+              <a:rPr lang="en-US"/>
               <a:t>Fourth level</a:t>
             </a:r>
           </a:p>
           <a:p>
             <a:pPr lvl="4"/>
             <a:r>
-              <a:rPr lang="en-US" smtClean="0"/>
+              <a:rPr lang="en-US"/>
               <a:t>Fifth level</a:t>
             </a:r>
-            <a:endParaRPr lang="en-US"/>
           </a:p>
         </p:txBody>
       </p:sp>
@@ -1772,7 +1773,7 @@
           <a:p>
             <a:fld id="{5BCAD085-E8A6-8845-BD4E-CB4CCA059FC4}" type="datetimeFigureOut">
               <a:rPr lang="en-US" smtClean="0"/>
-              <a:t>1/27/13</a:t>
+              <a:t>8/3/26</a:t>
             </a:fld>
             <a:endParaRPr lang="en-US"/>
           </a:p>
@@ -1866,10 +1867,9 @@
           <a:lstStyle/>
           <a:p>
             <a:r>
-              <a:rPr lang="en-US" smtClean="0"/>
+              <a:rPr lang="en-US"/>
               <a:t>Click to edit Master title style</a:t>
             </a:r>
-            <a:endParaRPr lang="en-US"/>
           </a:p>
         </p:txBody>
       </p:sp>
@@ -1890,7 +1890,7 @@
           <a:p>
             <a:fld id="{5BCAD085-E8A6-8845-BD4E-CB4CCA059FC4}" type="datetimeFigureOut">
               <a:rPr lang="en-US" smtClean="0"/>
-              <a:t>1/27/13</a:t>
+              <a:t>8/3/26</a:t>
             </a:fld>
             <a:endParaRPr lang="en-US"/>
           </a:p>
@@ -1985,7 +1985,7 @@
           <a:p>
             <a:fld id="{5BCAD085-E8A6-8845-BD4E-CB4CCA059FC4}" type="datetimeFigureOut">
               <a:rPr lang="en-US" smtClean="0"/>
-              <a:t>1/27/13</a:t>
+              <a:t>8/3/26</a:t>
             </a:fld>
             <a:endParaRPr lang="en-US"/>
           </a:p>
@@ -2088,10 +2088,9 @@
           </a:lstStyle>
           <a:p>
             <a:r>
-              <a:rPr lang="en-US" smtClean="0"/>
+              <a:rPr lang="en-US"/>
               <a:t>Click to edit Master title style</a:t>
             </a:r>
-            <a:endParaRPr lang="en-US"/>
           </a:p>
         </p:txBody>
       </p:sp>
@@ -2145,38 +2144,37 @@
           <a:p>
             <a:pPr lvl="0"/>
             <a:r>
-              <a:rPr lang="en-US" smtClean="0"/>
+              <a:rPr lang="en-US"/>
               <a:t>Click to edit Master text styles</a:t>
             </a:r>
           </a:p>
           <a:p>
             <a:pPr lvl="1"/>
             <a:r>
-              <a:rPr lang="en-US" smtClean="0"/>
+              <a:rPr lang="en-US"/>
               <a:t>Second level</a:t>
             </a:r>
           </a:p>
           <a:p>
             <a:pPr lvl="2"/>
             <a:r>
-              <a:rPr lang="en-US" smtClean="0"/>
+              <a:rPr lang="en-US"/>
               <a:t>Third level</a:t>
             </a:r>
           </a:p>
           <a:p>
             <a:pPr lvl="3"/>
             <a:r>
-              <a:rPr lang="en-US" smtClean="0"/>
+              <a:rPr lang="en-US"/>
               <a:t>Fourth level</a:t>
             </a:r>
           </a:p>
           <a:p>
             <a:pPr lvl="4"/>
             <a:r>
-              <a:rPr lang="en-US" smtClean="0"/>
+              <a:rPr lang="en-US"/>
               <a:t>Fifth level</a:t>
             </a:r>
-            <a:endParaRPr lang="en-US"/>
           </a:p>
         </p:txBody>
       </p:sp>
@@ -2239,7 +2237,7 @@
           <a:p>
             <a:pPr lvl="0"/>
             <a:r>
-              <a:rPr lang="en-US" smtClean="0"/>
+              <a:rPr lang="en-US"/>
               <a:t>Click to edit Master text styles</a:t>
             </a:r>
           </a:p>
@@ -2262,7 +2260,7 @@
           <a:p>
             <a:fld id="{5BCAD085-E8A6-8845-BD4E-CB4CCA059FC4}" type="datetimeFigureOut">
               <a:rPr lang="en-US" smtClean="0"/>
-              <a:t>1/27/13</a:t>
+              <a:t>8/3/26</a:t>
             </a:fld>
             <a:endParaRPr lang="en-US"/>
           </a:p>
@@ -2365,10 +2363,9 @@
           </a:lstStyle>
           <a:p>
             <a:r>
-              <a:rPr lang="en-US" smtClean="0"/>
+              <a:rPr lang="en-US"/>
               <a:t>Click to edit Master title style</a:t>
             </a:r>
-            <a:endParaRPr lang="en-US"/>
           </a:p>
         </p:txBody>
       </p:sp>
@@ -2492,7 +2489,7 @@
           <a:p>
             <a:pPr lvl="0"/>
             <a:r>
-              <a:rPr lang="en-US" smtClean="0"/>
+              <a:rPr lang="en-US"/>
               <a:t>Click to edit Master text styles</a:t>
             </a:r>
           </a:p>
@@ -2515,7 +2512,7 @@
           <a:p>
             <a:fld id="{5BCAD085-E8A6-8845-BD4E-CB4CCA059FC4}" type="datetimeFigureOut">
               <a:rPr lang="en-US" smtClean="0"/>
-              <a:t>1/27/13</a:t>
+              <a:t>8/3/26</a:t>
             </a:fld>
             <a:endParaRPr lang="en-US"/>
           </a:p>
@@ -2624,10 +2621,9 @@
           <a:lstStyle/>
           <a:p>
             <a:r>
-              <a:rPr lang="en-US" smtClean="0"/>
+              <a:rPr lang="en-US"/>
               <a:t>Click to edit Master title style</a:t>
             </a:r>
-            <a:endParaRPr lang="en-US"/>
           </a:p>
         </p:txBody>
       </p:sp>
@@ -2658,38 +2654,37 @@
           <a:p>
             <a:pPr lvl="0"/>
             <a:r>
-              <a:rPr lang="en-US" smtClean="0"/>
+              <a:rPr lang="en-US"/>
               <a:t>Click to edit Master text styles</a:t>
             </a:r>
           </a:p>
           <a:p>
             <a:pPr lvl="1"/>
             <a:r>
-              <a:rPr lang="en-US" smtClean="0"/>
+              <a:rPr lang="en-US"/>
               <a:t>Second level</a:t>
             </a:r>
           </a:p>
           <a:p>
             <a:pPr lvl="2"/>
             <a:r>
-              <a:rPr lang="en-US" smtClean="0"/>
+              <a:rPr lang="en-US"/>
               <a:t>Third level</a:t>
             </a:r>
           </a:p>
           <a:p>
             <a:pPr lvl="3"/>
             <a:r>
-              <a:rPr lang="en-US" smtClean="0"/>
+              <a:rPr lang="en-US"/>
               <a:t>Fourth level</a:t>
             </a:r>
           </a:p>
           <a:p>
             <a:pPr lvl="4"/>
             <a:r>
-              <a:rPr lang="en-US" smtClean="0"/>
+              <a:rPr lang="en-US"/>
               <a:t>Fifth level</a:t>
             </a:r>
-            <a:endParaRPr lang="en-US"/>
           </a:p>
         </p:txBody>
       </p:sp>
@@ -2728,7 +2723,7 @@
           <a:p>
             <a:fld id="{5BCAD085-E8A6-8845-BD4E-CB4CCA059FC4}" type="datetimeFigureOut">
               <a:rPr lang="en-US" smtClean="0"/>
-              <a:t>1/27/13</a:t>
+              <a:t>8/3/26</a:t>
             </a:fld>
             <a:endParaRPr lang="en-US"/>
           </a:p>
@@ -3087,7 +3082,7 @@
 </file>
 
 <file path=ppt/slides/slide1.xml><?xml version="1.0" encoding="utf-8"?>
-<p:sld xmlns:a="http://schemas.openxmlformats.org/drawingml/2006/main" xmlns:p="http://schemas.openxmlformats.org/presentationml/2006/main" xmlns:r="http://schemas.openxmlformats.org/officeDocument/2006/relationships">
+<p:sld xmlns:a="http://schemas.openxmlformats.org/drawingml/2006/main" xmlns:r="http://schemas.openxmlformats.org/officeDocument/2006/relationships" xmlns:p="http://schemas.openxmlformats.org/presentationml/2006/main">
   <p:cSld>
     <p:spTree>
       <p:nvGrpSpPr>
@@ -3095,7 +3090,14 @@
         <p:cNvGrpSpPr/>
         <p:nvPr/>
       </p:nvGrpSpPr>
-      <p:grpSpPr/>
+      <p:grpSpPr>
+        <a:xfrm>
+          <a:off x="0" y="0"/>
+          <a:ext cx="0" cy="0"/>
+          <a:chOff x="0" y="0"/>
+          <a:chExt cx="0" cy="0"/>
+        </a:xfrm>
+      </p:grpSpPr>
       <p:sp>
         <p:nvSpPr>
           <p:cNvPr id="2" name="Rectangle 1"/>
@@ -3136,6 +3138,7 @@
           <a:lstStyle/>
           <a:p>
             <a:pPr algn="ctr"/>
+            <a:endParaRPr/>
           </a:p>
         </p:txBody>
       </p:sp>
@@ -3179,6 +3182,7 @@
           <a:lstStyle/>
           <a:p>
             <a:pPr algn="ctr"/>
+            <a:endParaRPr/>
           </a:p>
         </p:txBody>
       </p:sp>
@@ -3328,7 +3332,7 @@
         <p:spPr>
           <a:xfrm>
             <a:off x="914400" y="5669280"/>
-            <a:ext cx="7315200" cy="548640"/>
+            <a:ext cx="5044971" cy="307777"/>
           </a:xfrm>
           <a:prstGeom prst="rect">
             <a:avLst/>
@@ -3349,8 +3353,42 @@
               </a:defRPr>
             </a:pPr>
             <a:r>
-              <a:t>제안자: 글로컬소프트 | 영광군의회 실무자 제출용</a:t>
-            </a:r>
+              <a:rPr dirty="0" err="1"/>
+              <a:t>제안자</a:t>
+            </a:r>
+            <a:r>
+              <a:rPr dirty="0"/>
+              <a:t>: 글로컬소프트 </a:t>
+            </a:r>
+            <a:r>
+              <a:rPr lang="ko-KR" altLang="en-US" dirty="0"/>
+              <a:t>대표 김종훈</a:t>
+            </a:r>
+            <a:r>
+              <a:rPr dirty="0"/>
+              <a:t>| </a:t>
+            </a:r>
+            <a:r>
+              <a:rPr dirty="0" err="1"/>
+              <a:t>영광군의회</a:t>
+            </a:r>
+            <a:r>
+              <a:rPr dirty="0"/>
+              <a:t> </a:t>
+            </a:r>
+            <a:r>
+              <a:rPr dirty="0" err="1"/>
+              <a:t>실무자</a:t>
+            </a:r>
+            <a:r>
+              <a:rPr dirty="0"/>
+              <a:t> </a:t>
+            </a:r>
+            <a:r>
+              <a:rPr dirty="0" err="1"/>
+              <a:t>제출용</a:t>
+            </a:r>
+            <a:endParaRPr dirty="0"/>
           </a:p>
         </p:txBody>
       </p:sp>
@@ -3363,7 +3401,7 @@
 </file>
 
 <file path=ppt/slides/slide2.xml><?xml version="1.0" encoding="utf-8"?>
-<p:sld xmlns:a="http://schemas.openxmlformats.org/drawingml/2006/main" xmlns:p="http://schemas.openxmlformats.org/presentationml/2006/main" xmlns:r="http://schemas.openxmlformats.org/officeDocument/2006/relationships">
+<p:sld xmlns:a="http://schemas.openxmlformats.org/drawingml/2006/main" xmlns:r="http://schemas.openxmlformats.org/officeDocument/2006/relationships" xmlns:p="http://schemas.openxmlformats.org/presentationml/2006/main">
   <p:cSld>
     <p:spTree>
       <p:nvGrpSpPr>
@@ -3371,7 +3409,14 @@
         <p:cNvGrpSpPr/>
         <p:nvPr/>
       </p:nvGrpSpPr>
-      <p:grpSpPr/>
+      <p:grpSpPr>
+        <a:xfrm>
+          <a:off x="0" y="0"/>
+          <a:ext cx="0" cy="0"/>
+          <a:chOff x="0" y="0"/>
+          <a:chExt cx="0" cy="0"/>
+        </a:xfrm>
+      </p:grpSpPr>
       <p:sp>
         <p:nvSpPr>
           <p:cNvPr id="2" name="Rectangle 1"/>
@@ -3412,6 +3457,7 @@
           <a:lstStyle/>
           <a:p>
             <a:pPr algn="ctr"/>
+            <a:endParaRPr/>
           </a:p>
         </p:txBody>
       </p:sp>
@@ -3455,6 +3501,7 @@
           <a:lstStyle/>
           <a:p>
             <a:pPr algn="ctr"/>
+            <a:endParaRPr/>
           </a:p>
         </p:txBody>
       </p:sp>
@@ -3566,7 +3613,7 @@
           </a:fontRef>
         </p:style>
         <p:txBody>
-          <a:bodyPr rtlCol="0" anchor="ctr" wrap="square"/>
+          <a:bodyPr wrap="square" rtlCol="0" anchor="ctr"/>
           <a:lstStyle/>
           <a:p>
             <a:pPr algn="ctr">
@@ -3577,8 +3624,46 @@
               </a:defRPr>
             </a:pPr>
             <a:r>
-              <a:t>❌ 기존 지자체/의정 홈페이지의 한계점</a:t>
-            </a:r>
+              <a:rPr dirty="0"/>
+              <a:t>❌ </a:t>
+            </a:r>
+            <a:r>
+              <a:rPr dirty="0" err="1"/>
+              <a:t>기존</a:t>
+            </a:r>
+            <a:r>
+              <a:rPr dirty="0"/>
+              <a:t> </a:t>
+            </a:r>
+            <a:r>
+              <a:rPr dirty="0" err="1"/>
+              <a:t>지자체</a:t>
+            </a:r>
+            <a:r>
+              <a:rPr dirty="0"/>
+              <a:t>/</a:t>
+            </a:r>
+            <a:r>
+              <a:rPr dirty="0" err="1"/>
+              <a:t>의정</a:t>
+            </a:r>
+            <a:r>
+              <a:rPr dirty="0"/>
+              <a:t> </a:t>
+            </a:r>
+            <a:r>
+              <a:rPr dirty="0" err="1"/>
+              <a:t>홈페이지의</a:t>
+            </a:r>
+            <a:r>
+              <a:rPr dirty="0"/>
+              <a:t> </a:t>
+            </a:r>
+            <a:r>
+              <a:rPr dirty="0" err="1"/>
+              <a:t>한계점</a:t>
+            </a:r>
+            <a:endParaRPr dirty="0"/>
           </a:p>
           <a:p>
             <a:pPr>
@@ -3592,8 +3677,110 @@
               </a:defRPr>
             </a:pPr>
             <a:r>
-              <a:t>• 단방향 정보 전달 중심: 공지사항 및 텍스트 회의록 열람 위주로 군민 참여 저조</a:t>
-            </a:r>
+              <a:rPr dirty="0"/>
+              <a:t>• </a:t>
+            </a:r>
+            <a:r>
+              <a:rPr dirty="0" err="1"/>
+              <a:t>단방향</a:t>
+            </a:r>
+            <a:r>
+              <a:rPr dirty="0"/>
+              <a:t> </a:t>
+            </a:r>
+            <a:r>
+              <a:rPr dirty="0" err="1"/>
+              <a:t>정보</a:t>
+            </a:r>
+            <a:r>
+              <a:rPr dirty="0"/>
+              <a:t> </a:t>
+            </a:r>
+            <a:r>
+              <a:rPr dirty="0" err="1"/>
+              <a:t>전달</a:t>
+            </a:r>
+            <a:r>
+              <a:rPr dirty="0"/>
+              <a:t> </a:t>
+            </a:r>
+            <a:r>
+              <a:rPr dirty="0" err="1"/>
+              <a:t>중심</a:t>
+            </a:r>
+            <a:r>
+              <a:rPr dirty="0"/>
+              <a:t>: </a:t>
+            </a:r>
+            <a:r>
+              <a:rPr dirty="0" err="1"/>
+              <a:t>공지사항</a:t>
+            </a:r>
+            <a:r>
+              <a:rPr dirty="0"/>
+              <a:t> </a:t>
+            </a:r>
+            <a:r>
+              <a:rPr dirty="0" err="1"/>
+              <a:t>및</a:t>
+            </a:r>
+            <a:r>
+              <a:rPr dirty="0"/>
+              <a:t> </a:t>
+            </a:r>
+            <a:r>
+              <a:rPr dirty="0" err="1"/>
+              <a:t>텍스트</a:t>
+            </a:r>
+            <a:r>
+              <a:rPr dirty="0"/>
+              <a:t> </a:t>
+            </a:r>
+            <a:r>
+              <a:rPr dirty="0" err="1"/>
+              <a:t>회의록</a:t>
+            </a:r>
+            <a:r>
+              <a:rPr dirty="0"/>
+              <a:t> </a:t>
+            </a:r>
+            <a:r>
+              <a:rPr dirty="0" err="1"/>
+              <a:t>열람</a:t>
+            </a:r>
+            <a:r>
+              <a:rPr dirty="0"/>
+              <a:t> </a:t>
+            </a:r>
+            <a:r>
+              <a:rPr dirty="0" err="1"/>
+              <a:t>위주로</a:t>
+            </a:r>
+            <a:r>
+              <a:rPr dirty="0"/>
+              <a:t> </a:t>
+            </a:r>
+            <a:r>
+              <a:rPr dirty="0" err="1"/>
+              <a:t>군민</a:t>
+            </a:r>
+            <a:r>
+              <a:rPr dirty="0"/>
+              <a:t> </a:t>
+            </a:r>
+            <a:r>
+              <a:rPr dirty="0" err="1"/>
+              <a:t>참여</a:t>
+            </a:r>
+            <a:r>
+              <a:rPr dirty="0"/>
+              <a:t> </a:t>
+            </a:r>
+            <a:r>
+              <a:rPr dirty="0" err="1"/>
+              <a:t>저조</a:t>
+            </a:r>
+            <a:endParaRPr dirty="0"/>
           </a:p>
           <a:p>
             <a:pPr>
@@ -3607,8 +3794,102 @@
               </a:defRPr>
             </a:pPr>
             <a:r>
-              <a:t>• 고령층 접근성 부족: 작은 글씨와 복잡한 메뉴 구조로 어르신 군민 소통 소외</a:t>
-            </a:r>
+              <a:rPr dirty="0"/>
+              <a:t>• </a:t>
+            </a:r>
+            <a:r>
+              <a:rPr dirty="0" err="1"/>
+              <a:t>고령층</a:t>
+            </a:r>
+            <a:r>
+              <a:rPr dirty="0"/>
+              <a:t> </a:t>
+            </a:r>
+            <a:r>
+              <a:rPr dirty="0" err="1"/>
+              <a:t>접근성</a:t>
+            </a:r>
+            <a:r>
+              <a:rPr dirty="0"/>
+              <a:t> </a:t>
+            </a:r>
+            <a:r>
+              <a:rPr dirty="0" err="1"/>
+              <a:t>부족</a:t>
+            </a:r>
+            <a:r>
+              <a:rPr dirty="0"/>
+              <a:t>: </a:t>
+            </a:r>
+            <a:r>
+              <a:rPr dirty="0" err="1"/>
+              <a:t>작은</a:t>
+            </a:r>
+            <a:r>
+              <a:rPr dirty="0"/>
+              <a:t> </a:t>
+            </a:r>
+            <a:r>
+              <a:rPr dirty="0" err="1"/>
+              <a:t>글씨와</a:t>
+            </a:r>
+            <a:r>
+              <a:rPr dirty="0"/>
+              <a:t> </a:t>
+            </a:r>
+            <a:r>
+              <a:rPr dirty="0" err="1"/>
+              <a:t>복잡한</a:t>
+            </a:r>
+            <a:r>
+              <a:rPr dirty="0"/>
+              <a:t> </a:t>
+            </a:r>
+            <a:r>
+              <a:rPr dirty="0" err="1"/>
+              <a:t>메뉴</a:t>
+            </a:r>
+            <a:r>
+              <a:rPr dirty="0"/>
+              <a:t> </a:t>
+            </a:r>
+            <a:r>
+              <a:rPr dirty="0" err="1"/>
+              <a:t>구조로</a:t>
+            </a:r>
+            <a:r>
+              <a:rPr dirty="0"/>
+              <a:t> </a:t>
+            </a:r>
+            <a:r>
+              <a:rPr dirty="0" err="1"/>
+              <a:t>어르신</a:t>
+            </a:r>
+            <a:r>
+              <a:rPr dirty="0"/>
+              <a:t> </a:t>
+            </a:r>
+            <a:r>
+              <a:rPr dirty="0" err="1"/>
+              <a:t>군민</a:t>
+            </a:r>
+            <a:r>
+              <a:rPr dirty="0"/>
+              <a:t> </a:t>
+            </a:r>
+            <a:r>
+              <a:rPr dirty="0" err="1"/>
+              <a:t>소통</a:t>
+            </a:r>
+            <a:r>
+              <a:rPr dirty="0"/>
+              <a:t> </a:t>
+            </a:r>
+            <a:r>
+              <a:rPr dirty="0" err="1"/>
+              <a:t>소외</a:t>
+            </a:r>
+            <a:endParaRPr dirty="0"/>
           </a:p>
           <a:p>
             <a:pPr>
@@ -3622,8 +3903,110 @@
               </a:defRPr>
             </a:pPr>
             <a:r>
-              <a:t>• 지역 밀착 소통 미흡: 영광 11개 읍·면별 맞춤 이슈 파악 및 의견 수렴 한계</a:t>
-            </a:r>
+              <a:rPr dirty="0"/>
+              <a:t>• </a:t>
+            </a:r>
+            <a:r>
+              <a:rPr dirty="0" err="1"/>
+              <a:t>지역</a:t>
+            </a:r>
+            <a:r>
+              <a:rPr dirty="0"/>
+              <a:t> </a:t>
+            </a:r>
+            <a:r>
+              <a:rPr dirty="0" err="1"/>
+              <a:t>밀착</a:t>
+            </a:r>
+            <a:r>
+              <a:rPr dirty="0"/>
+              <a:t> </a:t>
+            </a:r>
+            <a:r>
+              <a:rPr dirty="0" err="1"/>
+              <a:t>소통</a:t>
+            </a:r>
+            <a:r>
+              <a:rPr dirty="0"/>
+              <a:t> </a:t>
+            </a:r>
+            <a:r>
+              <a:rPr dirty="0" err="1"/>
+              <a:t>미흡</a:t>
+            </a:r>
+            <a:r>
+              <a:rPr dirty="0"/>
+              <a:t>: </a:t>
+            </a:r>
+            <a:r>
+              <a:rPr dirty="0" err="1"/>
+              <a:t>영광</a:t>
+            </a:r>
+            <a:r>
+              <a:rPr dirty="0"/>
+              <a:t> 11개 </a:t>
+            </a:r>
+            <a:r>
+              <a:rPr dirty="0" err="1"/>
+              <a:t>읍·면별</a:t>
+            </a:r>
+            <a:r>
+              <a:rPr dirty="0"/>
+              <a:t> </a:t>
+            </a:r>
+            <a:r>
+              <a:rPr dirty="0" err="1"/>
+              <a:t>맞춤</a:t>
+            </a:r>
+            <a:r>
+              <a:rPr dirty="0"/>
+              <a:t> </a:t>
+            </a:r>
+            <a:r>
+              <a:rPr dirty="0" err="1"/>
+              <a:t>이슈</a:t>
+            </a:r>
+            <a:r>
+              <a:rPr dirty="0"/>
+              <a:t> </a:t>
+            </a:r>
+            <a:r>
+              <a:rPr dirty="0" err="1"/>
+              <a:t>파악</a:t>
+            </a:r>
+            <a:r>
+              <a:rPr dirty="0"/>
+              <a:t> </a:t>
+            </a:r>
+            <a:r>
+              <a:rPr dirty="0" err="1"/>
+              <a:t>및</a:t>
+            </a:r>
+            <a:r>
+              <a:rPr dirty="0"/>
+              <a:t> </a:t>
+            </a:r>
+            <a:r>
+              <a:rPr dirty="0" err="1"/>
+              <a:t>의견</a:t>
+            </a:r>
+            <a:r>
+              <a:rPr dirty="0"/>
+              <a:t> </a:t>
+            </a:r>
+            <a:r>
+              <a:rPr dirty="0" err="1"/>
+              <a:t>수렴</a:t>
+            </a:r>
+            <a:r>
+              <a:rPr dirty="0"/>
+              <a:t> </a:t>
+            </a:r>
+            <a:r>
+              <a:rPr dirty="0" err="1"/>
+              <a:t>한계</a:t>
+            </a:r>
+            <a:endParaRPr dirty="0"/>
           </a:p>
           <a:p>
             <a:pPr>
@@ -3637,8 +4020,110 @@
               </a:defRPr>
             </a:pPr>
             <a:r>
-              <a:t>• 민원 처리 불투명성: 청원 접수 후 처리 단계와 안건 반영 과정 확인 어려움</a:t>
-            </a:r>
+              <a:rPr dirty="0"/>
+              <a:t>• </a:t>
+            </a:r>
+            <a:r>
+              <a:rPr dirty="0" err="1"/>
+              <a:t>민원</a:t>
+            </a:r>
+            <a:r>
+              <a:rPr dirty="0"/>
+              <a:t> </a:t>
+            </a:r>
+            <a:r>
+              <a:rPr dirty="0" err="1"/>
+              <a:t>처리</a:t>
+            </a:r>
+            <a:r>
+              <a:rPr dirty="0"/>
+              <a:t> </a:t>
+            </a:r>
+            <a:r>
+              <a:rPr dirty="0" err="1"/>
+              <a:t>불투명성</a:t>
+            </a:r>
+            <a:r>
+              <a:rPr dirty="0"/>
+              <a:t>: </a:t>
+            </a:r>
+            <a:r>
+              <a:rPr dirty="0" err="1"/>
+              <a:t>청원</a:t>
+            </a:r>
+            <a:r>
+              <a:rPr dirty="0"/>
+              <a:t> </a:t>
+            </a:r>
+            <a:r>
+              <a:rPr dirty="0" err="1"/>
+              <a:t>접수</a:t>
+            </a:r>
+            <a:r>
+              <a:rPr dirty="0"/>
+              <a:t> </a:t>
+            </a:r>
+            <a:r>
+              <a:rPr dirty="0" err="1"/>
+              <a:t>후</a:t>
+            </a:r>
+            <a:r>
+              <a:rPr dirty="0"/>
+              <a:t> </a:t>
+            </a:r>
+            <a:r>
+              <a:rPr dirty="0" err="1"/>
+              <a:t>처리</a:t>
+            </a:r>
+            <a:r>
+              <a:rPr dirty="0"/>
+              <a:t> </a:t>
+            </a:r>
+            <a:r>
+              <a:rPr dirty="0" err="1"/>
+              <a:t>단계와</a:t>
+            </a:r>
+            <a:r>
+              <a:rPr dirty="0"/>
+              <a:t> </a:t>
+            </a:r>
+            <a:r>
+              <a:rPr dirty="0" err="1"/>
+              <a:t>안건</a:t>
+            </a:r>
+            <a:r>
+              <a:rPr dirty="0"/>
+              <a:t> </a:t>
+            </a:r>
+            <a:r>
+              <a:rPr dirty="0" err="1"/>
+              <a:t>반영</a:t>
+            </a:r>
+            <a:r>
+              <a:rPr dirty="0"/>
+              <a:t> </a:t>
+            </a:r>
+            <a:r>
+              <a:rPr dirty="0" err="1"/>
+              <a:t>과정</a:t>
+            </a:r>
+            <a:r>
+              <a:rPr dirty="0"/>
+              <a:t> </a:t>
+            </a:r>
+            <a:r>
+              <a:rPr dirty="0" err="1"/>
+              <a:t>확인</a:t>
+            </a:r>
+            <a:r>
+              <a:rPr dirty="0"/>
+              <a:t> </a:t>
+            </a:r>
+            <a:r>
+              <a:rPr dirty="0" err="1"/>
+              <a:t>어려움</a:t>
+            </a:r>
+            <a:endParaRPr dirty="0"/>
           </a:p>
         </p:txBody>
       </p:sp>
@@ -3680,7 +4165,7 @@
           </a:fontRef>
         </p:style>
         <p:txBody>
-          <a:bodyPr rtlCol="0" anchor="ctr" wrap="square"/>
+          <a:bodyPr wrap="square" rtlCol="0" anchor="ctr"/>
           <a:lstStyle/>
           <a:p>
             <a:pPr algn="ctr">
@@ -3765,7 +4250,7 @@
 </file>
 
 <file path=ppt/slides/slide3.xml><?xml version="1.0" encoding="utf-8"?>
-<p:sld xmlns:a="http://schemas.openxmlformats.org/drawingml/2006/main" xmlns:p="http://schemas.openxmlformats.org/presentationml/2006/main" xmlns:r="http://schemas.openxmlformats.org/officeDocument/2006/relationships">
+<p:sld xmlns:a="http://schemas.openxmlformats.org/drawingml/2006/main" xmlns:r="http://schemas.openxmlformats.org/officeDocument/2006/relationships" xmlns:p="http://schemas.openxmlformats.org/presentationml/2006/main">
   <p:cSld>
     <p:spTree>
       <p:nvGrpSpPr>
@@ -3773,7 +4258,14 @@
         <p:cNvGrpSpPr/>
         <p:nvPr/>
       </p:nvGrpSpPr>
-      <p:grpSpPr/>
+      <p:grpSpPr>
+        <a:xfrm>
+          <a:off x="0" y="0"/>
+          <a:ext cx="0" cy="0"/>
+          <a:chOff x="0" y="0"/>
+          <a:chExt cx="0" cy="0"/>
+        </a:xfrm>
+      </p:grpSpPr>
       <p:sp>
         <p:nvSpPr>
           <p:cNvPr id="2" name="Rectangle 1"/>
@@ -3814,6 +4306,7 @@
           <a:lstStyle/>
           <a:p>
             <a:pPr algn="ctr"/>
+            <a:endParaRPr/>
           </a:p>
         </p:txBody>
       </p:sp>
@@ -3857,6 +4350,7 @@
           <a:lstStyle/>
           <a:p>
             <a:pPr algn="ctr"/>
+            <a:endParaRPr/>
           </a:p>
         </p:txBody>
       </p:sp>
@@ -3968,7 +4462,7 @@
           </a:fontRef>
         </p:style>
         <p:txBody>
-          <a:bodyPr rtlCol="0" anchor="ctr" wrap="square"/>
+          <a:bodyPr wrap="square" rtlCol="0" anchor="ctr"/>
           <a:lstStyle/>
           <a:p>
             <a:pPr algn="ctr">
@@ -4037,7 +4531,7 @@
           </a:fontRef>
         </p:style>
         <p:txBody>
-          <a:bodyPr rtlCol="0" anchor="ctr" wrap="square"/>
+          <a:bodyPr wrap="square" rtlCol="0" anchor="ctr"/>
           <a:lstStyle/>
           <a:p>
             <a:pPr algn="ctr">
@@ -4106,7 +4600,7 @@
           </a:fontRef>
         </p:style>
         <p:txBody>
-          <a:bodyPr rtlCol="0" anchor="ctr" wrap="square"/>
+          <a:bodyPr wrap="square" rtlCol="0" anchor="ctr"/>
           <a:lstStyle/>
           <a:p>
             <a:pPr algn="ctr">
@@ -4175,7 +4669,7 @@
           </a:fontRef>
         </p:style>
         <p:txBody>
-          <a:bodyPr rtlCol="0" anchor="ctr" wrap="square"/>
+          <a:bodyPr wrap="square" rtlCol="0" anchor="ctr"/>
           <a:lstStyle/>
           <a:p>
             <a:pPr algn="ctr">
@@ -4244,7 +4738,7 @@
           </a:fontRef>
         </p:style>
         <p:txBody>
-          <a:bodyPr rtlCol="0" anchor="ctr" wrap="square"/>
+          <a:bodyPr wrap="square" rtlCol="0" anchor="ctr"/>
           <a:lstStyle/>
           <a:p>
             <a:pPr algn="ctr">
@@ -4284,7 +4778,7 @@
 </file>
 
 <file path=ppt/slides/slide4.xml><?xml version="1.0" encoding="utf-8"?>
-<p:sld xmlns:a="http://schemas.openxmlformats.org/drawingml/2006/main" xmlns:p="http://schemas.openxmlformats.org/presentationml/2006/main" xmlns:r="http://schemas.openxmlformats.org/officeDocument/2006/relationships">
+<p:sld xmlns:a="http://schemas.openxmlformats.org/drawingml/2006/main" xmlns:r="http://schemas.openxmlformats.org/officeDocument/2006/relationships" xmlns:p="http://schemas.openxmlformats.org/presentationml/2006/main">
   <p:cSld>
     <p:spTree>
       <p:nvGrpSpPr>
@@ -4292,7 +4786,14 @@
         <p:cNvGrpSpPr/>
         <p:nvPr/>
       </p:nvGrpSpPr>
-      <p:grpSpPr/>
+      <p:grpSpPr>
+        <a:xfrm>
+          <a:off x="0" y="0"/>
+          <a:ext cx="0" cy="0"/>
+          <a:chOff x="0" y="0"/>
+          <a:chExt cx="0" cy="0"/>
+        </a:xfrm>
+      </p:grpSpPr>
       <p:sp>
         <p:nvSpPr>
           <p:cNvPr id="2" name="Rectangle 1"/>
@@ -4333,6 +4834,7 @@
           <a:lstStyle/>
           <a:p>
             <a:pPr algn="ctr"/>
+            <a:endParaRPr/>
           </a:p>
         </p:txBody>
       </p:sp>
@@ -4376,6 +4878,7 @@
           <a:lstStyle/>
           <a:p>
             <a:pPr algn="ctr"/>
+            <a:endParaRPr/>
           </a:p>
         </p:txBody>
       </p:sp>
@@ -4455,7 +4958,13 @@
           <p:cNvGraphicFramePr>
             <a:graphicFrameLocks noGrp="1"/>
           </p:cNvGraphicFramePr>
-          <p:nvPr/>
+          <p:nvPr>
+            <p:extLst>
+              <p:ext uri="{D42A27DB-BD31-4B8C-83A1-F6EECF244321}">
+                <p14:modId xmlns:p14="http://schemas.microsoft.com/office/powerpoint/2010/main" val="2494861950"/>
+              </p:ext>
+            </p:extLst>
+          </p:nvPr>
         </p:nvGraphicFramePr>
         <p:xfrm>
           <a:off x="731520" y="1463040"/>
@@ -4468,9 +4977,27 @@
                 <a:tableStyleId>{5C22544A-7EE6-4342-B048-85BDC9FD1C3A}</a:tableStyleId>
               </a:tblPr>
               <a:tblGrid>
-                <a:gridCol w="2011680"/>
-                <a:gridCol w="4297680"/>
-                <a:gridCol w="4419295"/>
+                <a:gridCol w="2011680">
+                  <a:extLst>
+                    <a:ext uri="{9D8B030D-6E8A-4147-A177-3AD203B41FA5}">
+                      <a16:colId xmlns:a16="http://schemas.microsoft.com/office/drawing/2014/main" val="20000"/>
+                    </a:ext>
+                  </a:extLst>
+                </a:gridCol>
+                <a:gridCol w="4297680">
+                  <a:extLst>
+                    <a:ext uri="{9D8B030D-6E8A-4147-A177-3AD203B41FA5}">
+                      <a16:colId xmlns:a16="http://schemas.microsoft.com/office/drawing/2014/main" val="20001"/>
+                    </a:ext>
+                  </a:extLst>
+                </a:gridCol>
+                <a:gridCol w="4419295">
+                  <a:extLst>
+                    <a:ext uri="{9D8B030D-6E8A-4147-A177-3AD203B41FA5}">
+                      <a16:colId xmlns:a16="http://schemas.microsoft.com/office/drawing/2014/main" val="20002"/>
+                    </a:ext>
+                  </a:extLst>
+                </a:gridCol>
               </a:tblGrid>
               <a:tr h="762000">
                 <a:tc>
@@ -4486,11 +5013,13 @@
                         </a:defRPr>
                       </a:pPr>
                       <a:r>
+                        <a:rPr dirty="0" err="1"/>
                         <a:t>구분</a:t>
                       </a:r>
+                      <a:endParaRPr dirty="0"/>
                     </a:p>
                   </a:txBody>
-                  <a:tcPr>
+                  <a:tcPr anchor="ctr">
                     <a:solidFill>
                       <a:srgbClr val="0B2D52"/>
                     </a:solidFill>
@@ -4509,11 +5038,32 @@
                         </a:defRPr>
                       </a:pPr>
                       <a:r>
-                        <a:t>기존 영광군의회 홈페이지 ❌</a:t>
+                        <a:rPr dirty="0" err="1"/>
+                        <a:t>기존</a:t>
+                      </a:r>
+                      <a:r>
+                        <a:rPr dirty="0"/>
+                        <a:t> </a:t>
+                      </a:r>
+                      <a:r>
+                        <a:rPr dirty="0" err="1"/>
+                        <a:t>영광군의회</a:t>
+                      </a:r>
+                      <a:r>
+                        <a:rPr dirty="0"/>
+                        <a:t> </a:t>
+                      </a:r>
+                      <a:r>
+                        <a:rPr dirty="0" err="1"/>
+                        <a:t>홈페이지</a:t>
+                      </a:r>
+                      <a:r>
+                        <a:rPr dirty="0"/>
+                        <a:t> ❌</a:t>
                       </a:r>
                     </a:p>
                   </a:txBody>
-                  <a:tcPr>
+                  <a:tcPr anchor="ctr">
                     <a:solidFill>
                       <a:srgbClr val="0B2D52"/>
                     </a:solidFill>
@@ -4532,16 +5082,42 @@
                         </a:defRPr>
                       </a:pPr>
                       <a:r>
-                        <a:t>새로 구축한 '열린소통 ON' ⭕</a:t>
+                        <a:rPr dirty="0" err="1"/>
+                        <a:t>새로</a:t>
+                      </a:r>
+                      <a:r>
+                        <a:rPr dirty="0"/>
+                        <a:t> </a:t>
+                      </a:r>
+                      <a:r>
+                        <a:rPr dirty="0" err="1"/>
+                        <a:t>구축한</a:t>
+                      </a:r>
+                      <a:r>
+                        <a:rPr dirty="0"/>
+                        <a:t> '</a:t>
+                      </a:r>
+                      <a:r>
+                        <a:rPr dirty="0" err="1"/>
+                        <a:t>열린소통</a:t>
+                      </a:r>
+                      <a:r>
+                        <a:rPr dirty="0"/>
+                        <a:t> ON' ⭕</a:t>
                       </a:r>
                     </a:p>
                   </a:txBody>
-                  <a:tcPr>
+                  <a:tcPr anchor="ctr">
                     <a:solidFill>
                       <a:srgbClr val="00A896"/>
                     </a:solidFill>
                   </a:tcPr>
                 </a:tc>
+                <a:extLst>
+                  <a:ext uri="{0D108BD9-81ED-4DB2-BD59-A6C34878D82A}">
+                    <a16:rowId xmlns:a16="http://schemas.microsoft.com/office/drawing/2014/main" val="10000"/>
+                  </a:ext>
+                </a:extLst>
               </a:tr>
               <a:tr h="762000">
                 <a:tc>
@@ -4561,7 +5137,7 @@
                       </a:r>
                     </a:p>
                   </a:txBody>
-                  <a:tcPr>
+                  <a:tcPr anchor="ctr">
                     <a:solidFill>
                       <a:srgbClr val="F1F5F9"/>
                     </a:solidFill>
@@ -4580,11 +5156,64 @@
                         </a:defRPr>
                       </a:pPr>
                       <a:r>
-                        <a:t>단방향 정보 전달 (공지사항, 회의록 단순 조회)</a:t>
+                        <a:rPr dirty="0" err="1"/>
+                        <a:t>단방향</a:t>
+                      </a:r>
+                      <a:r>
+                        <a:rPr dirty="0"/>
+                        <a:t> </a:t>
+                      </a:r>
+                      <a:r>
+                        <a:rPr dirty="0" err="1"/>
+                        <a:t>정보</a:t>
+                      </a:r>
+                      <a:r>
+                        <a:rPr dirty="0"/>
+                        <a:t> </a:t>
+                      </a:r>
+                      <a:r>
+                        <a:rPr dirty="0" err="1"/>
+                        <a:t>전달</a:t>
+                      </a:r>
+                      <a:r>
+                        <a:rPr dirty="0"/>
+                        <a:t> (</a:t>
+                      </a:r>
+                      <a:r>
+                        <a:rPr dirty="0" err="1"/>
+                        <a:t>공지사항</a:t>
+                      </a:r>
+                      <a:r>
+                        <a:rPr dirty="0"/>
+                        <a:t>, </a:t>
+                      </a:r>
+                      <a:r>
+                        <a:rPr dirty="0" err="1"/>
+                        <a:t>회의록</a:t>
+                      </a:r>
+                      <a:r>
+                        <a:rPr dirty="0"/>
+                        <a:t> </a:t>
+                      </a:r>
+                      <a:r>
+                        <a:rPr dirty="0" err="1"/>
+                        <a:t>단순</a:t>
+                      </a:r>
+                      <a:r>
+                        <a:rPr dirty="0"/>
+                        <a:t> </a:t>
+                      </a:r>
+                      <a:r>
+                        <a:rPr dirty="0" err="1"/>
+                        <a:t>조회</a:t>
+                      </a:r>
+                      <a:r>
+                        <a:rPr dirty="0"/>
+                        <a:t>)</a:t>
                       </a:r>
                     </a:p>
                   </a:txBody>
-                  <a:tcPr>
+                  <a:tcPr anchor="ctr">
                     <a:solidFill>
                       <a:srgbClr val="F1F5F9"/>
                     </a:solidFill>
@@ -4603,16 +5232,82 @@
                         </a:defRPr>
                       </a:pPr>
                       <a:r>
-                        <a:t>쌍방향 참여형 (군민청원 동의, 조례안 찬반 직접 투표)</a:t>
+                        <a:rPr dirty="0" err="1"/>
+                        <a:t>쌍방향</a:t>
+                      </a:r>
+                      <a:r>
+                        <a:rPr dirty="0"/>
+                        <a:t> </a:t>
+                      </a:r>
+                      <a:r>
+                        <a:rPr dirty="0" err="1"/>
+                        <a:t>참여형</a:t>
+                      </a:r>
+                      <a:r>
+                        <a:rPr dirty="0"/>
+                        <a:t> (</a:t>
+                      </a:r>
+                      <a:r>
+                        <a:rPr dirty="0" err="1"/>
+                        <a:t>군민청원</a:t>
+                      </a:r>
+                      <a:r>
+                        <a:rPr dirty="0"/>
+                        <a:t> </a:t>
+                      </a:r>
+                      <a:r>
+                        <a:rPr dirty="0" err="1"/>
+                        <a:t>동의</a:t>
+                      </a:r>
+                      <a:r>
+                        <a:rPr dirty="0"/>
+                        <a:t>, </a:t>
+                      </a:r>
+                      <a:r>
+                        <a:rPr dirty="0" err="1"/>
+                        <a:t>조례안</a:t>
+                      </a:r>
+                      <a:r>
+                        <a:rPr dirty="0"/>
+                        <a:t> </a:t>
+                      </a:r>
+                      <a:r>
+                        <a:rPr dirty="0" err="1"/>
+                        <a:t>찬반</a:t>
+                      </a:r>
+                      <a:r>
+                        <a:rPr dirty="0"/>
+                        <a:t> </a:t>
+                      </a:r>
+                      <a:r>
+                        <a:rPr dirty="0" err="1"/>
+                        <a:t>직접</a:t>
+                      </a:r>
+                      <a:r>
+                        <a:rPr dirty="0"/>
+                        <a:t> </a:t>
+                      </a:r>
+                      <a:r>
+                        <a:rPr dirty="0" err="1"/>
+                        <a:t>투표</a:t>
+                      </a:r>
+                      <a:r>
+                        <a:rPr dirty="0"/>
+                        <a:t>)</a:t>
                       </a:r>
                     </a:p>
                   </a:txBody>
-                  <a:tcPr>
+                  <a:tcPr anchor="ctr">
                     <a:solidFill>
                       <a:srgbClr val="F1F5F9"/>
                     </a:solidFill>
                   </a:tcPr>
                 </a:tc>
+                <a:extLst>
+                  <a:ext uri="{0D108BD9-81ED-4DB2-BD59-A6C34878D82A}">
+                    <a16:rowId xmlns:a16="http://schemas.microsoft.com/office/drawing/2014/main" val="10001"/>
+                  </a:ext>
+                </a:extLst>
               </a:tr>
               <a:tr h="762000">
                 <a:tc>
@@ -4632,7 +5327,7 @@
                       </a:r>
                     </a:p>
                   </a:txBody>
-                  <a:tcPr>
+                  <a:tcPr anchor="ctr">
                     <a:solidFill>
                       <a:srgbClr val="FFFFFF"/>
                     </a:solidFill>
@@ -4651,11 +5346,64 @@
                         </a:defRPr>
                       </a:pPr>
                       <a:r>
-                        <a:t>작은 글씨, 복잡한 메뉴 (어르신 이용 어려움)</a:t>
+                        <a:rPr dirty="0" err="1"/>
+                        <a:t>작은</a:t>
+                      </a:r>
+                      <a:r>
+                        <a:rPr dirty="0"/>
+                        <a:t> </a:t>
+                      </a:r>
+                      <a:r>
+                        <a:rPr dirty="0" err="1"/>
+                        <a:t>글씨</a:t>
+                      </a:r>
+                      <a:r>
+                        <a:rPr dirty="0"/>
+                        <a:t>, </a:t>
+                      </a:r>
+                      <a:r>
+                        <a:rPr dirty="0" err="1"/>
+                        <a:t>복잡한</a:t>
+                      </a:r>
+                      <a:r>
+                        <a:rPr dirty="0"/>
+                        <a:t> </a:t>
+                      </a:r>
+                      <a:r>
+                        <a:rPr dirty="0" err="1"/>
+                        <a:t>메뉴</a:t>
+                      </a:r>
+                      <a:r>
+                        <a:rPr dirty="0"/>
+                        <a:t> (</a:t>
+                      </a:r>
+                      <a:r>
+                        <a:rPr dirty="0" err="1"/>
+                        <a:t>어르신</a:t>
+                      </a:r>
+                      <a:r>
+                        <a:rPr dirty="0"/>
+                        <a:t> </a:t>
+                      </a:r>
+                      <a:r>
+                        <a:rPr dirty="0" err="1"/>
+                        <a:t>이용</a:t>
+                      </a:r>
+                      <a:r>
+                        <a:rPr dirty="0"/>
+                        <a:t> </a:t>
+                      </a:r>
+                      <a:r>
+                        <a:rPr dirty="0" err="1"/>
+                        <a:t>어려움</a:t>
+                      </a:r>
+                      <a:r>
+                        <a:rPr dirty="0"/>
+                        <a:t>)</a:t>
                       </a:r>
                     </a:p>
                   </a:txBody>
-                  <a:tcPr>
+                  <a:tcPr anchor="ctr">
                     <a:solidFill>
                       <a:srgbClr val="FFFFFF"/>
                     </a:solidFill>
@@ -4674,16 +5422,79 @@
                         </a:defRPr>
                       </a:pPr>
                       <a:r>
-                        <a:t>어르신 쉬운 모드 (글자 120% 확대, 고대비) 원클릭 지원</a:t>
-                      </a:r>
+                        <a:rPr dirty="0" err="1"/>
+                        <a:t>어르신</a:t>
+                      </a:r>
+                      <a:r>
+                        <a:rPr dirty="0"/>
+                        <a:t> </a:t>
+                      </a:r>
+                      <a:r>
+                        <a:rPr dirty="0" err="1"/>
+                        <a:t>쉬운</a:t>
+                      </a:r>
+                      <a:r>
+                        <a:rPr dirty="0"/>
+                        <a:t> </a:t>
+                      </a:r>
+                      <a:r>
+                        <a:rPr dirty="0" err="1"/>
+                        <a:t>모드</a:t>
+                      </a:r>
+                      <a:r>
+                        <a:rPr dirty="0"/>
+                        <a:t> (</a:t>
+                      </a:r>
+                      <a:r>
+                        <a:rPr dirty="0" err="1"/>
+                        <a:t>글자</a:t>
+                      </a:r>
+                      <a:r>
+                        <a:rPr dirty="0"/>
+                        <a:t> 120% </a:t>
+                      </a:r>
+                      <a:r>
+                        <a:rPr dirty="0" err="1"/>
+                        <a:t>확대</a:t>
+                      </a:r>
+                      <a:r>
+                        <a:rPr dirty="0"/>
+                        <a:t>, </a:t>
+                      </a:r>
+                      <a:r>
+                        <a:rPr dirty="0" err="1"/>
+                        <a:t>고대비</a:t>
+                      </a:r>
+                      <a:r>
+                        <a:rPr dirty="0"/>
+                        <a:t>) </a:t>
+                      </a:r>
+                      <a:r>
+                        <a:rPr dirty="0" err="1"/>
+                        <a:t>원클릭</a:t>
+                      </a:r>
+                      <a:r>
+                        <a:rPr dirty="0"/>
+                        <a:t> </a:t>
+                      </a:r>
+                      <a:r>
+                        <a:rPr dirty="0" err="1"/>
+                        <a:t>지원</a:t>
+                      </a:r>
+                      <a:endParaRPr dirty="0"/>
                     </a:p>
                   </a:txBody>
-                  <a:tcPr>
+                  <a:tcPr anchor="ctr">
                     <a:solidFill>
                       <a:srgbClr val="FFFFFF"/>
                     </a:solidFill>
                   </a:tcPr>
                 </a:tc>
+                <a:extLst>
+                  <a:ext uri="{0D108BD9-81ED-4DB2-BD59-A6C34878D82A}">
+                    <a16:rowId xmlns:a16="http://schemas.microsoft.com/office/drawing/2014/main" val="10002"/>
+                  </a:ext>
+                </a:extLst>
               </a:tr>
               <a:tr h="762000">
                 <a:tc>
@@ -4703,7 +5514,7 @@
                       </a:r>
                     </a:p>
                   </a:txBody>
-                  <a:tcPr>
+                  <a:tcPr anchor="ctr">
                     <a:solidFill>
                       <a:srgbClr val="F1F5F9"/>
                     </a:solidFill>
@@ -4722,11 +5533,45 @@
                         </a:defRPr>
                       </a:pPr>
                       <a:r>
-                        <a:t>영광군 전체 통합 게시판 위주</a:t>
-                      </a:r>
+                        <a:rPr dirty="0" err="1"/>
+                        <a:t>영광군</a:t>
+                      </a:r>
+                      <a:r>
+                        <a:rPr dirty="0"/>
+                        <a:t> </a:t>
+                      </a:r>
+                      <a:r>
+                        <a:rPr dirty="0" err="1"/>
+                        <a:t>전체</a:t>
+                      </a:r>
+                      <a:r>
+                        <a:rPr dirty="0"/>
+                        <a:t> </a:t>
+                      </a:r>
+                      <a:r>
+                        <a:rPr dirty="0" err="1"/>
+                        <a:t>통합</a:t>
+                      </a:r>
+                      <a:r>
+                        <a:rPr dirty="0"/>
+                        <a:t> </a:t>
+                      </a:r>
+                      <a:r>
+                        <a:rPr dirty="0" err="1"/>
+                        <a:t>게시판</a:t>
+                      </a:r>
+                      <a:r>
+                        <a:rPr dirty="0"/>
+                        <a:t> </a:t>
+                      </a:r>
+                      <a:r>
+                        <a:rPr dirty="0" err="1"/>
+                        <a:t>위주</a:t>
+                      </a:r>
+                      <a:endParaRPr dirty="0"/>
                     </a:p>
                   </a:txBody>
-                  <a:tcPr>
+                  <a:tcPr anchor="ctr">
                     <a:solidFill>
                       <a:srgbClr val="F1F5F9"/>
                     </a:solidFill>
@@ -4745,16 +5590,66 @@
                         </a:defRPr>
                       </a:pPr>
                       <a:r>
-                        <a:t>영광 11개 읍·면 소통지도 (동네별 이슈 핀포인트)</a:t>
+                        <a:rPr dirty="0" err="1"/>
+                        <a:t>영광</a:t>
+                      </a:r>
+                      <a:r>
+                        <a:rPr dirty="0"/>
+                        <a:t> 11개 </a:t>
+                      </a:r>
+                      <a:r>
+                        <a:rPr dirty="0" err="1"/>
+                        <a:t>읍·면</a:t>
+                      </a:r>
+                      <a:r>
+                        <a:rPr dirty="0"/>
+                        <a:t> </a:t>
+                      </a:r>
+                      <a:r>
+                        <a:rPr dirty="0" err="1"/>
+                        <a:t>소통지도</a:t>
+                      </a:r>
+                      <a:r>
+                        <a:rPr dirty="0"/>
+                        <a:t> (</a:t>
+                      </a:r>
+                      <a:r>
+                        <a:rPr dirty="0" err="1"/>
+                        <a:t>동네별</a:t>
+                      </a:r>
+                      <a:r>
+                        <a:rPr dirty="0"/>
+                        <a:t> </a:t>
+                      </a:r>
+                      <a:r>
+                        <a:rPr dirty="0" err="1"/>
+                        <a:t>이슈</a:t>
+                      </a:r>
+                      <a:r>
+                        <a:rPr dirty="0"/>
+                        <a:t> </a:t>
+                      </a:r>
+                      <a:r>
+                        <a:rPr dirty="0" err="1"/>
+                        <a:t>핀포인트</a:t>
+                      </a:r>
+                      <a:r>
+                        <a:rPr dirty="0"/>
+                        <a:t>)</a:t>
                       </a:r>
                     </a:p>
                   </a:txBody>
-                  <a:tcPr>
+                  <a:tcPr anchor="ctr">
                     <a:solidFill>
                       <a:srgbClr val="F1F5F9"/>
                     </a:solidFill>
                   </a:tcPr>
                 </a:tc>
+                <a:extLst>
+                  <a:ext uri="{0D108BD9-81ED-4DB2-BD59-A6C34878D82A}">
+                    <a16:rowId xmlns:a16="http://schemas.microsoft.com/office/drawing/2014/main" val="10003"/>
+                  </a:ext>
+                </a:extLst>
               </a:tr>
               <a:tr h="762000">
                 <a:tc>
@@ -4774,7 +5669,7 @@
                       </a:r>
                     </a:p>
                   </a:txBody>
-                  <a:tcPr>
+                  <a:tcPr anchor="ctr">
                     <a:solidFill>
                       <a:srgbClr val="FFFFFF"/>
                     </a:solidFill>
@@ -4797,7 +5692,7 @@
                       </a:r>
                     </a:p>
                   </a:txBody>
-                  <a:tcPr>
+                  <a:tcPr anchor="ctr">
                     <a:solidFill>
                       <a:srgbClr val="FFFFFF"/>
                     </a:solidFill>
@@ -4816,16 +5711,51 @@
                         </a:defRPr>
                       </a:pPr>
                       <a:r>
-                        <a:t>[접수➔동의➔답변➔반영] 4단계 실시간 진행바 공개</a:t>
-                      </a:r>
+                        <a:rPr dirty="0"/>
+                        <a:t>[</a:t>
+                      </a:r>
+                      <a:r>
+                        <a:rPr dirty="0" err="1"/>
+                        <a:t>접수➔동의➔답변➔반영</a:t>
+                      </a:r>
+                      <a:r>
+                        <a:rPr dirty="0"/>
+                        <a:t>] 4단계 </a:t>
+                      </a:r>
+                      <a:r>
+                        <a:rPr dirty="0" err="1"/>
+                        <a:t>실시간</a:t>
+                      </a:r>
+                      <a:r>
+                        <a:rPr dirty="0"/>
+                        <a:t> </a:t>
+                      </a:r>
+                      <a:r>
+                        <a:rPr dirty="0" err="1"/>
+                        <a:t>진행바</a:t>
+                      </a:r>
+                      <a:r>
+                        <a:rPr dirty="0"/>
+                        <a:t> </a:t>
+                      </a:r>
+                      <a:r>
+                        <a:rPr dirty="0" err="1"/>
+                        <a:t>공개</a:t>
+                      </a:r>
+                      <a:endParaRPr dirty="0"/>
                     </a:p>
                   </a:txBody>
-                  <a:tcPr>
+                  <a:tcPr anchor="ctr">
                     <a:solidFill>
                       <a:srgbClr val="FFFFFF"/>
                     </a:solidFill>
                   </a:tcPr>
                 </a:tc>
+                <a:extLst>
+                  <a:ext uri="{0D108BD9-81ED-4DB2-BD59-A6C34878D82A}">
+                    <a16:rowId xmlns:a16="http://schemas.microsoft.com/office/drawing/2014/main" val="10004"/>
+                  </a:ext>
+                </a:extLst>
               </a:tr>
               <a:tr h="762000">
                 <a:tc>
@@ -4845,7 +5775,7 @@
                       </a:r>
                     </a:p>
                   </a:txBody>
-                  <a:tcPr>
+                  <a:tcPr anchor="ctr">
                     <a:solidFill>
                       <a:srgbClr val="F1F5F9"/>
                     </a:solidFill>
@@ -4868,7 +5798,7 @@
                       </a:r>
                     </a:p>
                   </a:txBody>
-                  <a:tcPr>
+                  <a:tcPr anchor="ctr">
                     <a:solidFill>
                       <a:srgbClr val="F1F5F9"/>
                     </a:solidFill>
@@ -4887,16 +5817,75 @@
                         </a:defRPr>
                       </a:pPr>
                       <a:r>
-                        <a:t>AI 실시간 발언 요약 &amp; 1:1 의원 직접 건의함 제공</a:t>
-                      </a:r>
+                        <a:rPr dirty="0"/>
+                        <a:t>AI </a:t>
+                      </a:r>
+                      <a:r>
+                        <a:rPr dirty="0" err="1"/>
+                        <a:t>실시간</a:t>
+                      </a:r>
+                      <a:r>
+                        <a:rPr dirty="0"/>
+                        <a:t> </a:t>
+                      </a:r>
+                      <a:r>
+                        <a:rPr dirty="0" err="1"/>
+                        <a:t>발언</a:t>
+                      </a:r>
+                      <a:r>
+                        <a:rPr dirty="0"/>
+                        <a:t> </a:t>
+                      </a:r>
+                      <a:r>
+                        <a:rPr dirty="0" err="1"/>
+                        <a:t>요약</a:t>
+                      </a:r>
+                      <a:r>
+                        <a:rPr dirty="0"/>
+                        <a:t> &amp; 1:1 </a:t>
+                      </a:r>
+                      <a:r>
+                        <a:rPr dirty="0" err="1"/>
+                        <a:t>의원</a:t>
+                      </a:r>
+                      <a:r>
+                        <a:rPr dirty="0"/>
+                        <a:t> </a:t>
+                      </a:r>
+                      <a:r>
+                        <a:rPr dirty="0" err="1"/>
+                        <a:t>직접</a:t>
+                      </a:r>
+                      <a:r>
+                        <a:rPr dirty="0"/>
+                        <a:t> </a:t>
+                      </a:r>
+                      <a:r>
+                        <a:rPr dirty="0" err="1"/>
+                        <a:t>건의함</a:t>
+                      </a:r>
+                      <a:r>
+                        <a:rPr dirty="0"/>
+                        <a:t> </a:t>
+                      </a:r>
+                      <a:r>
+                        <a:rPr dirty="0" err="1"/>
+                        <a:t>제공</a:t>
+                      </a:r>
+                      <a:endParaRPr dirty="0"/>
                     </a:p>
                   </a:txBody>
-                  <a:tcPr>
+                  <a:tcPr anchor="ctr">
                     <a:solidFill>
                       <a:srgbClr val="F1F5F9"/>
                     </a:solidFill>
                   </a:tcPr>
                 </a:tc>
+                <a:extLst>
+                  <a:ext uri="{0D108BD9-81ED-4DB2-BD59-A6C34878D82A}">
+                    <a16:rowId xmlns:a16="http://schemas.microsoft.com/office/drawing/2014/main" val="10005"/>
+                  </a:ext>
+                </a:extLst>
               </a:tr>
             </a:tbl>
           </a:graphicData>
@@ -4911,7 +5900,7 @@
 </file>
 
 <file path=ppt/slides/slide5.xml><?xml version="1.0" encoding="utf-8"?>
-<p:sld xmlns:a="http://schemas.openxmlformats.org/drawingml/2006/main" xmlns:p="http://schemas.openxmlformats.org/presentationml/2006/main" xmlns:r="http://schemas.openxmlformats.org/officeDocument/2006/relationships">
+<p:sld xmlns:a="http://schemas.openxmlformats.org/drawingml/2006/main" xmlns:r="http://schemas.openxmlformats.org/officeDocument/2006/relationships" xmlns:p="http://schemas.openxmlformats.org/presentationml/2006/main">
   <p:cSld>
     <p:spTree>
       <p:nvGrpSpPr>
@@ -4919,7 +5908,14 @@
         <p:cNvGrpSpPr/>
         <p:nvPr/>
       </p:nvGrpSpPr>
-      <p:grpSpPr/>
+      <p:grpSpPr>
+        <a:xfrm>
+          <a:off x="0" y="0"/>
+          <a:ext cx="0" cy="0"/>
+          <a:chOff x="0" y="0"/>
+          <a:chExt cx="0" cy="0"/>
+        </a:xfrm>
+      </p:grpSpPr>
       <p:sp>
         <p:nvSpPr>
           <p:cNvPr id="2" name="Rectangle 1"/>
@@ -4960,6 +5956,7 @@
           <a:lstStyle/>
           <a:p>
             <a:pPr algn="ctr"/>
+            <a:endParaRPr/>
           </a:p>
         </p:txBody>
       </p:sp>
@@ -5003,6 +6000,7 @@
           <a:lstStyle/>
           <a:p>
             <a:pPr algn="ctr"/>
+            <a:endParaRPr/>
           </a:p>
         </p:txBody>
       </p:sp>
@@ -5149,7 +6147,7 @@
           </a:fontRef>
         </p:style>
         <p:txBody>
-          <a:bodyPr rtlCol="0" anchor="ctr" wrap="square"/>
+          <a:bodyPr wrap="square" rtlCol="0" anchor="ctr"/>
           <a:lstStyle/>
           <a:p>
             <a:pPr algn="ctr">
@@ -5248,7 +6246,7 @@
           </a:fontRef>
         </p:style>
         <p:txBody>
-          <a:bodyPr rtlCol="0" anchor="ctr" wrap="square"/>
+          <a:bodyPr wrap="square" rtlCol="0" anchor="ctr"/>
           <a:lstStyle/>
           <a:p>
             <a:pPr algn="ctr">
@@ -5347,7 +6345,7 @@
           </a:fontRef>
         </p:style>
         <p:txBody>
-          <a:bodyPr rtlCol="0" anchor="ctr" wrap="square"/>
+          <a:bodyPr wrap="square" rtlCol="0" anchor="ctr"/>
           <a:lstStyle/>
           <a:p>
             <a:pPr algn="ctr">
@@ -5446,7 +6444,7 @@
           </a:fontRef>
         </p:style>
         <p:txBody>
-          <a:bodyPr rtlCol="0" anchor="ctr" wrap="square"/>
+          <a:bodyPr wrap="square" rtlCol="0" anchor="ctr"/>
           <a:lstStyle/>
           <a:p>
             <a:pPr algn="ctr">
@@ -5545,7 +6543,7 @@
           </a:fontRef>
         </p:style>
         <p:txBody>
-          <a:bodyPr rtlCol="0" anchor="ctr" wrap="square"/>
+          <a:bodyPr wrap="square" rtlCol="0" anchor="ctr"/>
           <a:lstStyle/>
           <a:p>
             <a:pPr algn="ctr">
@@ -5644,7 +6642,7 @@
           </a:fontRef>
         </p:style>
         <p:txBody>
-          <a:bodyPr rtlCol="0" anchor="ctr" wrap="square"/>
+          <a:bodyPr wrap="square" rtlCol="0" anchor="ctr"/>
           <a:lstStyle/>
           <a:p>
             <a:pPr algn="ctr">
@@ -5743,7 +6741,7 @@
           </a:fontRef>
         </p:style>
         <p:txBody>
-          <a:bodyPr rtlCol="0" anchor="ctr" wrap="square"/>
+          <a:bodyPr wrap="square" rtlCol="0" anchor="ctr"/>
           <a:lstStyle/>
           <a:p>
             <a:pPr algn="ctr">
@@ -5842,7 +6840,7 @@
           </a:fontRef>
         </p:style>
         <p:txBody>
-          <a:bodyPr rtlCol="0" anchor="ctr" wrap="square"/>
+          <a:bodyPr wrap="square" rtlCol="0" anchor="ctr"/>
           <a:lstStyle/>
           <a:p>
             <a:pPr algn="ctr">
@@ -5912,7 +6910,7 @@
 </file>
 
 <file path=ppt/slides/slide6.xml><?xml version="1.0" encoding="utf-8"?>
-<p:sld xmlns:a="http://schemas.openxmlformats.org/drawingml/2006/main" xmlns:p="http://schemas.openxmlformats.org/presentationml/2006/main" xmlns:r="http://schemas.openxmlformats.org/officeDocument/2006/relationships">
+<p:sld xmlns:a="http://schemas.openxmlformats.org/drawingml/2006/main" xmlns:r="http://schemas.openxmlformats.org/officeDocument/2006/relationships" xmlns:p="http://schemas.openxmlformats.org/presentationml/2006/main">
   <p:cSld>
     <p:spTree>
       <p:nvGrpSpPr>
@@ -5920,7 +6918,14 @@
         <p:cNvGrpSpPr/>
         <p:nvPr/>
       </p:nvGrpSpPr>
-      <p:grpSpPr/>
+      <p:grpSpPr>
+        <a:xfrm>
+          <a:off x="0" y="0"/>
+          <a:ext cx="0" cy="0"/>
+          <a:chOff x="0" y="0"/>
+          <a:chExt cx="0" cy="0"/>
+        </a:xfrm>
+      </p:grpSpPr>
       <p:sp>
         <p:nvSpPr>
           <p:cNvPr id="2" name="Rectangle 1"/>
@@ -5961,6 +6966,7 @@
           <a:lstStyle/>
           <a:p>
             <a:pPr algn="ctr"/>
+            <a:endParaRPr/>
           </a:p>
         </p:txBody>
       </p:sp>
@@ -6004,6 +7010,7 @@
           <a:lstStyle/>
           <a:p>
             <a:pPr algn="ctr"/>
+            <a:endParaRPr/>
           </a:p>
         </p:txBody>
       </p:sp>
@@ -6115,7 +7122,7 @@
           </a:fontRef>
         </p:style>
         <p:txBody>
-          <a:bodyPr rtlCol="0" anchor="ctr" wrap="square"/>
+          <a:bodyPr wrap="square" rtlCol="0" anchor="ctr"/>
           <a:lstStyle/>
           <a:p>
             <a:pPr algn="ctr">
@@ -6200,7 +7207,7 @@
 </file>
 
 <file path=ppt/slides/slide7.xml><?xml version="1.0" encoding="utf-8"?>
-<p:sld xmlns:a="http://schemas.openxmlformats.org/drawingml/2006/main" xmlns:p="http://schemas.openxmlformats.org/presentationml/2006/main" xmlns:r="http://schemas.openxmlformats.org/officeDocument/2006/relationships">
+<p:sld xmlns:a="http://schemas.openxmlformats.org/drawingml/2006/main" xmlns:r="http://schemas.openxmlformats.org/officeDocument/2006/relationships" xmlns:p="http://schemas.openxmlformats.org/presentationml/2006/main">
   <p:cSld>
     <p:spTree>
       <p:nvGrpSpPr>
@@ -6208,7 +7215,14 @@
         <p:cNvGrpSpPr/>
         <p:nvPr/>
       </p:nvGrpSpPr>
-      <p:grpSpPr/>
+      <p:grpSpPr>
+        <a:xfrm>
+          <a:off x="0" y="0"/>
+          <a:ext cx="0" cy="0"/>
+          <a:chOff x="0" y="0"/>
+          <a:chExt cx="0" cy="0"/>
+        </a:xfrm>
+      </p:grpSpPr>
       <p:sp>
         <p:nvSpPr>
           <p:cNvPr id="2" name="Rectangle 1"/>
@@ -6249,6 +7263,7 @@
           <a:lstStyle/>
           <a:p>
             <a:pPr algn="ctr"/>
+            <a:endParaRPr/>
           </a:p>
         </p:txBody>
       </p:sp>
@@ -6292,6 +7307,7 @@
           <a:lstStyle/>
           <a:p>
             <a:pPr algn="ctr"/>
+            <a:endParaRPr/>
           </a:p>
         </p:txBody>
       </p:sp>
@@ -6403,7 +7419,7 @@
           </a:fontRef>
         </p:style>
         <p:txBody>
-          <a:bodyPr rtlCol="0" anchor="ctr" wrap="square"/>
+          <a:bodyPr wrap="square" rtlCol="0" anchor="ctr"/>
           <a:lstStyle/>
           <a:p>
             <a:pPr algn="ctr">
@@ -6500,7 +7516,7 @@
           </a:fontRef>
         </p:style>
         <p:txBody>
-          <a:bodyPr rtlCol="0" anchor="ctr" wrap="square"/>
+          <a:bodyPr wrap="square" rtlCol="0" anchor="ctr"/>
           <a:lstStyle/>
           <a:p>
             <a:pPr algn="ctr">
@@ -6570,7 +7586,7 @@
 </file>
 
 <file path=ppt/slides/slide8.xml><?xml version="1.0" encoding="utf-8"?>
-<p:sld xmlns:a="http://schemas.openxmlformats.org/drawingml/2006/main" xmlns:p="http://schemas.openxmlformats.org/presentationml/2006/main" xmlns:r="http://schemas.openxmlformats.org/officeDocument/2006/relationships">
+<p:sld xmlns:a="http://schemas.openxmlformats.org/drawingml/2006/main" xmlns:r="http://schemas.openxmlformats.org/officeDocument/2006/relationships" xmlns:p="http://schemas.openxmlformats.org/presentationml/2006/main">
   <p:cSld>
     <p:spTree>
       <p:nvGrpSpPr>
@@ -6578,7 +7594,14 @@
         <p:cNvGrpSpPr/>
         <p:nvPr/>
       </p:nvGrpSpPr>
-      <p:grpSpPr/>
+      <p:grpSpPr>
+        <a:xfrm>
+          <a:off x="0" y="0"/>
+          <a:ext cx="0" cy="0"/>
+          <a:chOff x="0" y="0"/>
+          <a:chExt cx="0" cy="0"/>
+        </a:xfrm>
+      </p:grpSpPr>
       <p:sp>
         <p:nvSpPr>
           <p:cNvPr id="2" name="Rectangle 1"/>
@@ -6587,7 +7610,7 @@
         </p:nvSpPr>
         <p:spPr>
           <a:xfrm>
-            <a:off x="0" y="0"/>
+            <a:off x="-25095" y="0"/>
             <a:ext cx="12191695" cy="1005840"/>
           </a:xfrm>
           <a:prstGeom prst="rect">
@@ -6619,6 +7642,7 @@
           <a:lstStyle/>
           <a:p>
             <a:pPr algn="ctr"/>
+            <a:endParaRPr/>
           </a:p>
         </p:txBody>
       </p:sp>
@@ -6662,6 +7686,7 @@
           <a:lstStyle/>
           <a:p>
             <a:pPr algn="ctr"/>
+            <a:endParaRPr/>
           </a:p>
         </p:txBody>
       </p:sp>
@@ -6773,7 +7798,7 @@
           </a:fontRef>
         </p:style>
         <p:txBody>
-          <a:bodyPr rtlCol="0" anchor="ctr" wrap="square"/>
+          <a:bodyPr wrap="square" rtlCol="0" anchor="ctr"/>
           <a:lstStyle/>
           <a:p>
             <a:pPr algn="ctr">
@@ -6914,7 +7939,7 @@
           </a:fontRef>
         </p:style>
         <p:txBody>
-          <a:bodyPr rtlCol="0" anchor="ctr" wrap="square"/>
+          <a:bodyPr wrap="square" rtlCol="0" anchor="ctr"/>
           <a:lstStyle/>
           <a:p>
             <a:pPr algn="ctr">
@@ -7026,7 +8051,7 @@
 </file>
 
 <file path=ppt/slides/slide9.xml><?xml version="1.0" encoding="utf-8"?>
-<p:sld xmlns:a="http://schemas.openxmlformats.org/drawingml/2006/main" xmlns:p="http://schemas.openxmlformats.org/presentationml/2006/main" xmlns:r="http://schemas.openxmlformats.org/officeDocument/2006/relationships">
+<p:sld xmlns:a="http://schemas.openxmlformats.org/drawingml/2006/main" xmlns:r="http://schemas.openxmlformats.org/officeDocument/2006/relationships" xmlns:p="http://schemas.openxmlformats.org/presentationml/2006/main">
   <p:cSld>
     <p:spTree>
       <p:nvGrpSpPr>
@@ -7034,7 +8059,14 @@
         <p:cNvGrpSpPr/>
         <p:nvPr/>
       </p:nvGrpSpPr>
-      <p:grpSpPr/>
+      <p:grpSpPr>
+        <a:xfrm>
+          <a:off x="0" y="0"/>
+          <a:ext cx="0" cy="0"/>
+          <a:chOff x="0" y="0"/>
+          <a:chExt cx="0" cy="0"/>
+        </a:xfrm>
+      </p:grpSpPr>
       <p:sp>
         <p:nvSpPr>
           <p:cNvPr id="2" name="Rectangle 1"/>
@@ -7075,6 +8107,7 @@
           <a:lstStyle/>
           <a:p>
             <a:pPr algn="ctr"/>
+            <a:endParaRPr/>
           </a:p>
         </p:txBody>
       </p:sp>
@@ -7086,8 +8119,8 @@
         </p:nvSpPr>
         <p:spPr>
           <a:xfrm>
-            <a:off x="914400" y="1828800"/>
-            <a:ext cx="10362895" cy="3200400"/>
+            <a:off x="2460077" y="1828800"/>
+            <a:ext cx="7271541" cy="2780248"/>
           </a:xfrm>
           <a:prstGeom prst="rect">
             <a:avLst/>
@@ -7108,8 +8141,10 @@
               </a:defRPr>
             </a:pPr>
             <a:r>
+              <a:rPr dirty="0" err="1"/>
               <a:t>감사합니다</a:t>
             </a:r>
+            <a:endParaRPr dirty="0"/>
           </a:p>
           <a:p>
             <a:pPr algn="ctr">
@@ -7123,11 +8158,107 @@
               </a:defRPr>
             </a:pPr>
             <a:r>
-              <a:t>영광군의회 군민소통 전용 웹플랫폼 '열린소통 ON'과 함께</a:t>
-            </a:r>
-            <a:br/>
-            <a:r>
-              <a:t>군민 중심의 참여 의정을 만드시길 기원합니다.</a:t>
+              <a:rPr dirty="0" err="1"/>
+              <a:t>영광군의회</a:t>
+            </a:r>
+            <a:r>
+              <a:rPr dirty="0"/>
+              <a:t> </a:t>
+            </a:r>
+            <a:r>
+              <a:rPr dirty="0" err="1"/>
+              <a:t>군민소통</a:t>
+            </a:r>
+            <a:r>
+              <a:rPr dirty="0"/>
+              <a:t> </a:t>
+            </a:r>
+            <a:r>
+              <a:rPr dirty="0" err="1"/>
+              <a:t>전용</a:t>
+            </a:r>
+            <a:r>
+              <a:rPr dirty="0"/>
+              <a:t> </a:t>
+            </a:r>
+            <a:r>
+              <a:rPr dirty="0" err="1"/>
+              <a:t>웹플랫폼</a:t>
+            </a:r>
+            <a:r>
+              <a:rPr dirty="0"/>
+              <a:t> '</a:t>
+            </a:r>
+            <a:r>
+              <a:rPr dirty="0" err="1"/>
+              <a:t>열린소통</a:t>
+            </a:r>
+            <a:r>
+              <a:rPr dirty="0"/>
+              <a:t> </a:t>
+            </a:r>
+            <a:r>
+              <a:rPr dirty="0" err="1"/>
+              <a:t>ON'과</a:t>
+            </a:r>
+            <a:r>
+              <a:rPr dirty="0"/>
+              <a:t> </a:t>
+            </a:r>
+            <a:r>
+              <a:rPr dirty="0" err="1"/>
+              <a:t>함께</a:t>
+            </a:r>
+            <a:br>
+              <a:rPr dirty="0"/>
+            </a:br>
+            <a:r>
+              <a:rPr dirty="0" err="1"/>
+              <a:t>군민</a:t>
+            </a:r>
+            <a:r>
+              <a:rPr dirty="0"/>
+              <a:t> </a:t>
+            </a:r>
+            <a:r>
+              <a:rPr dirty="0" err="1"/>
+              <a:t>중심의</a:t>
+            </a:r>
+            <a:r>
+              <a:rPr dirty="0"/>
+              <a:t> </a:t>
+            </a:r>
+            <a:r>
+              <a:rPr dirty="0" err="1"/>
+              <a:t>참여</a:t>
+            </a:r>
+            <a:r>
+              <a:rPr dirty="0"/>
+              <a:t> </a:t>
+            </a:r>
+            <a:r>
+              <a:rPr dirty="0" err="1"/>
+              <a:t>의정을</a:t>
+            </a:r>
+            <a:r>
+              <a:rPr dirty="0"/>
+              <a:t> </a:t>
+            </a:r>
+            <a:r>
+              <a:rPr dirty="0" err="1"/>
+              <a:t>만드시길</a:t>
+            </a:r>
+            <a:r>
+              <a:rPr dirty="0"/>
+              <a:t> </a:t>
+            </a:r>
+            <a:r>
+              <a:rPr dirty="0" err="1"/>
+              <a:t>기원합니다</a:t>
+            </a:r>
+            <a:r>
+              <a:rPr dirty="0"/>
+              <a:t>.</a:t>
             </a:r>
           </a:p>
           <a:p>
@@ -7142,16 +8273,104 @@
               </a:defRPr>
             </a:pPr>
             <a:r>
-              <a:t>🌐 데모 시연: http://localhost:8085/ (관리자: /admin.html)</a:t>
-            </a:r>
-            <a:br/>
-            <a:r>
-              <a:t>📂 깃허브 저장소: https://github.com/shokun2002-maker/ygcouncil</a:t>
-            </a:r>
-            <a:br/>
-            <a:r>
-              <a:t>제작/지원: 글로컬소프트</a:t>
-            </a:r>
+              <a:rPr dirty="0"/>
+              <a:t>🌐 </a:t>
+            </a:r>
+            <a:r>
+              <a:rPr dirty="0" err="1"/>
+              <a:t>데모</a:t>
+            </a:r>
+            <a:r>
+              <a:rPr dirty="0"/>
+              <a:t> </a:t>
+            </a:r>
+            <a:r>
+              <a:rPr dirty="0" err="1"/>
+              <a:t>시연</a:t>
+            </a:r>
+            <a:r>
+              <a:rPr dirty="0"/>
+              <a:t>: http://localhost:8085/ (</a:t>
+            </a:r>
+            <a:r>
+              <a:rPr dirty="0" err="1"/>
+              <a:t>관리자</a:t>
+            </a:r>
+            <a:r>
+              <a:rPr dirty="0"/>
+              <a:t>: /</a:t>
+            </a:r>
+            <a:r>
+              <a:rPr dirty="0" err="1"/>
+              <a:t>admin.html</a:t>
+            </a:r>
+            <a:r>
+              <a:rPr dirty="0"/>
+              <a:t>)</a:t>
+            </a:r>
+            <a:br>
+              <a:rPr dirty="0"/>
+            </a:br>
+            <a:r>
+              <a:rPr dirty="0"/>
+              <a:t>📂 </a:t>
+            </a:r>
+            <a:r>
+              <a:rPr dirty="0" err="1"/>
+              <a:t>깃허브</a:t>
+            </a:r>
+            <a:r>
+              <a:rPr dirty="0"/>
+              <a:t> </a:t>
+            </a:r>
+            <a:r>
+              <a:rPr dirty="0" err="1"/>
+              <a:t>저장소</a:t>
+            </a:r>
+            <a:r>
+              <a:rPr dirty="0"/>
+              <a:t>: https://</a:t>
+            </a:r>
+            <a:r>
+              <a:rPr dirty="0" err="1"/>
+              <a:t>github.com</a:t>
+            </a:r>
+            <a:r>
+              <a:rPr dirty="0"/>
+              <a:t>/shokun2002-maker/</a:t>
+            </a:r>
+            <a:r>
+              <a:rPr dirty="0" err="1"/>
+              <a:t>ygcouncil</a:t>
+            </a:r>
+            <a:br>
+              <a:rPr dirty="0"/>
+            </a:br>
+            <a:r>
+              <a:rPr dirty="0" err="1"/>
+              <a:t>제작</a:t>
+            </a:r>
+            <a:r>
+              <a:rPr dirty="0"/>
+              <a:t>/</a:t>
+            </a:r>
+            <a:r>
+              <a:rPr dirty="0" err="1"/>
+              <a:t>지원</a:t>
+            </a:r>
+            <a:r>
+              <a:rPr dirty="0"/>
+              <a:t>: 글로컬소프트</a:t>
+            </a:r>
+            <a:r>
+              <a:rPr lang="ko-KR" altLang="en-US" dirty="0"/>
+              <a:t> 대표 김종훈 </a:t>
+            </a:r>
+            <a:r>
+              <a:rPr lang="en-US" altLang="ko-KR"/>
+              <a:t>(010-9354-7929)</a:t>
+            </a:r>
+            <a:endParaRPr/>
           </a:p>
         </p:txBody>
       </p:sp>

</xml_diff>